<commit_message>
Update PowerPoint for song #191 in FUBC - Українські
</commit_message>
<xml_diff>
--- a/fubc-ua/191-Серце нове із клітинок живих (Пісні Спасенних №189).pptx
+++ b/fubc-ua/191-Серце нове із клітинок живих (Пісні Спасенних №189).pptx
@@ -1891,23 +1891,6 @@
             </a:r>
             <a:endParaRPr lang="en-US" sz="5200" dirty="0"/>
           </a:p>
-          <a:p>
-            <a:pPr algn="ctr" indent="0" marL="0">
-              <a:buNone/>
-            </a:pPr>
-            <a:r>
-              <a:rPr lang="en-US" sz="5200" b="1" dirty="0">
-                <a:solidFill>
-                  <a:srgbClr val="FFFFFF"/>
-                </a:solidFill>
-                <a:latin typeface="Arial" pitchFamily="34" charset="0"/>
-                <a:ea typeface="Arial" pitchFamily="34" charset="-122"/>
-                <a:cs typeface="Arial" pitchFamily="34" charset="-120"/>
-              </a:rPr>
-              <a:t>(Пісні Спасенних №189)</a:t>
-            </a:r>
-            <a:endParaRPr lang="en-US" sz="5200" dirty="0"/>
-          </a:p>
         </p:txBody>
       </p:sp>
     </p:spTree>
@@ -2089,7 +2072,7 @@
               <a:buNone/>
             </a:pPr>
             <a:r>
-              <a:rPr lang="en-US" sz="5000" b="1" i="1" dirty="0">
+              <a:rPr lang="en-US" sz="4500" b="1" i="1" dirty="0">
                 <a:solidFill>
                   <a:srgbClr val="FFFFFF"/>
                 </a:solidFill>
@@ -2097,16 +2080,16 @@
                 <a:ea typeface="Arial" pitchFamily="34" charset="-122"/>
                 <a:cs typeface="Arial" pitchFamily="34" charset="-120"/>
               </a:rPr>
-              <a:t>Серце нове (серце нове)</a:t>
-            </a:r>
-            <a:endParaRPr lang="en-US" sz="5000" dirty="0"/>
+              <a:t>Серце нове Бог дав мені,</a:t>
+            </a:r>
+            <a:endParaRPr lang="en-US" sz="4500" dirty="0"/>
           </a:p>
           <a:p>
             <a:pPr algn="ctr" indent="0" marL="0">
               <a:buNone/>
             </a:pPr>
             <a:r>
-              <a:rPr lang="en-US" sz="5000" b="1" i="1" dirty="0">
+              <a:rPr lang="en-US" sz="4500" b="1" i="1" dirty="0">
                 <a:solidFill>
                   <a:srgbClr val="FFFFFF"/>
                 </a:solidFill>
@@ -2114,43 +2097,9 @@
                 <a:ea typeface="Arial" pitchFamily="34" charset="-122"/>
                 <a:cs typeface="Arial" pitchFamily="34" charset="-120"/>
               </a:rPr>
-              <a:t>Бог дав мені (дав мені),</a:t>
-            </a:r>
-            <a:endParaRPr lang="en-US" sz="5000" dirty="0"/>
-          </a:p>
-          <a:p>
-            <a:pPr algn="ctr" indent="0" marL="0">
-              <a:buNone/>
-            </a:pPr>
-            <a:r>
-              <a:rPr lang="en-US" sz="5000" b="1" i="1" dirty="0">
-                <a:solidFill>
-                  <a:srgbClr val="FFFFFF"/>
-                </a:solidFill>
-                <a:latin typeface="Arial" pitchFamily="34" charset="0"/>
-                <a:ea typeface="Arial" pitchFamily="34" charset="-122"/>
-                <a:cs typeface="Arial" pitchFamily="34" charset="-120"/>
-              </a:rPr>
-              <a:t>радість спасіння (радість спасіння)</a:t>
-            </a:r>
-            <a:endParaRPr lang="en-US" sz="5000" dirty="0"/>
-          </a:p>
-          <a:p>
-            <a:pPr algn="ctr" indent="0" marL="0">
-              <a:buNone/>
-            </a:pPr>
-            <a:r>
-              <a:rPr lang="en-US" sz="5000" b="1" i="1" dirty="0">
-                <a:solidFill>
-                  <a:srgbClr val="FFFFFF"/>
-                </a:solidFill>
-                <a:latin typeface="Arial" pitchFamily="34" charset="0"/>
-                <a:ea typeface="Arial" pitchFamily="34" charset="-122"/>
-                <a:cs typeface="Arial" pitchFamily="34" charset="-120"/>
-              </a:rPr>
-              <a:t>і вічне життя дарував (дарував).</a:t>
-            </a:r>
-            <a:endParaRPr lang="en-US" sz="5000" dirty="0"/>
+              <a:t>радість спасіння і вічне життя дарував.</a:t>
+            </a:r>
+            <a:endParaRPr lang="en-US" sz="4500" dirty="0"/>
           </a:p>
         </p:txBody>
       </p:sp>
@@ -2404,7 +2353,7 @@
               <a:buNone/>
             </a:pPr>
             <a:r>
-              <a:rPr lang="en-US" sz="5000" b="1" i="1" dirty="0">
+              <a:rPr lang="en-US" sz="4500" b="1" i="1" dirty="0">
                 <a:solidFill>
                   <a:srgbClr val="FFFFFF"/>
                 </a:solidFill>
@@ -2412,16 +2361,16 @@
                 <a:ea typeface="Arial" pitchFamily="34" charset="-122"/>
                 <a:cs typeface="Arial" pitchFamily="34" charset="-120"/>
               </a:rPr>
-              <a:t>Серце нове (серце нове)</a:t>
-            </a:r>
-            <a:endParaRPr lang="en-US" sz="5000" dirty="0"/>
+              <a:t>Серце нове Бог дав мені,</a:t>
+            </a:r>
+            <a:endParaRPr lang="en-US" sz="4500" dirty="0"/>
           </a:p>
           <a:p>
             <a:pPr algn="ctr" indent="0" marL="0">
               <a:buNone/>
             </a:pPr>
             <a:r>
-              <a:rPr lang="en-US" sz="5000" b="1" i="1" dirty="0">
+              <a:rPr lang="en-US" sz="4500" b="1" i="1" dirty="0">
                 <a:solidFill>
                   <a:srgbClr val="FFFFFF"/>
                 </a:solidFill>
@@ -2429,43 +2378,9 @@
                 <a:ea typeface="Arial" pitchFamily="34" charset="-122"/>
                 <a:cs typeface="Arial" pitchFamily="34" charset="-120"/>
               </a:rPr>
-              <a:t>Бог дав мені (дав мені),</a:t>
-            </a:r>
-            <a:endParaRPr lang="en-US" sz="5000" dirty="0"/>
-          </a:p>
-          <a:p>
-            <a:pPr algn="ctr" indent="0" marL="0">
-              <a:buNone/>
-            </a:pPr>
-            <a:r>
-              <a:rPr lang="en-US" sz="5000" b="1" i="1" dirty="0">
-                <a:solidFill>
-                  <a:srgbClr val="FFFFFF"/>
-                </a:solidFill>
-                <a:latin typeface="Arial" pitchFamily="34" charset="0"/>
-                <a:ea typeface="Arial" pitchFamily="34" charset="-122"/>
-                <a:cs typeface="Arial" pitchFamily="34" charset="-120"/>
-              </a:rPr>
-              <a:t>радість спасіння (радість спасіння)</a:t>
-            </a:r>
-            <a:endParaRPr lang="en-US" sz="5000" dirty="0"/>
-          </a:p>
-          <a:p>
-            <a:pPr algn="ctr" indent="0" marL="0">
-              <a:buNone/>
-            </a:pPr>
-            <a:r>
-              <a:rPr lang="en-US" sz="5000" b="1" i="1" dirty="0">
-                <a:solidFill>
-                  <a:srgbClr val="FFFFFF"/>
-                </a:solidFill>
-                <a:latin typeface="Arial" pitchFamily="34" charset="0"/>
-                <a:ea typeface="Arial" pitchFamily="34" charset="-122"/>
-                <a:cs typeface="Arial" pitchFamily="34" charset="-120"/>
-              </a:rPr>
-              <a:t>і вічне життя дарував (дарував).</a:t>
-            </a:r>
-            <a:endParaRPr lang="en-US" sz="5000" dirty="0"/>
+              <a:t>радість спасіння і вічне життя дарував.</a:t>
+            </a:r>
+            <a:endParaRPr lang="en-US" sz="4500" dirty="0"/>
           </a:p>
         </p:txBody>
       </p:sp>
@@ -2648,7 +2563,7 @@
               <a:buNone/>
             </a:pPr>
             <a:r>
-              <a:rPr lang="en-US" sz="5000" b="1" i="1" dirty="0">
+              <a:rPr lang="en-US" sz="4500" b="1" i="1" dirty="0">
                 <a:solidFill>
                   <a:srgbClr val="FFFFFF"/>
                 </a:solidFill>
@@ -2656,16 +2571,16 @@
                 <a:ea typeface="Arial" pitchFamily="34" charset="-122"/>
                 <a:cs typeface="Arial" pitchFamily="34" charset="-120"/>
               </a:rPr>
-              <a:t>Серце нове (серце нове)</a:t>
-            </a:r>
-            <a:endParaRPr lang="en-US" sz="5000" dirty="0"/>
+              <a:t>Серце нове Бог дав мені,</a:t>
+            </a:r>
+            <a:endParaRPr lang="en-US" sz="4500" dirty="0"/>
           </a:p>
           <a:p>
             <a:pPr algn="ctr" indent="0" marL="0">
               <a:buNone/>
             </a:pPr>
             <a:r>
-              <a:rPr lang="en-US" sz="5000" b="1" i="1" dirty="0">
+              <a:rPr lang="en-US" sz="4500" b="1" i="1" dirty="0">
                 <a:solidFill>
                   <a:srgbClr val="FFFFFF"/>
                 </a:solidFill>
@@ -2673,43 +2588,9 @@
                 <a:ea typeface="Arial" pitchFamily="34" charset="-122"/>
                 <a:cs typeface="Arial" pitchFamily="34" charset="-120"/>
               </a:rPr>
-              <a:t>Бог дав мені (дав мені),</a:t>
-            </a:r>
-            <a:endParaRPr lang="en-US" sz="5000" dirty="0"/>
-          </a:p>
-          <a:p>
-            <a:pPr algn="ctr" indent="0" marL="0">
-              <a:buNone/>
-            </a:pPr>
-            <a:r>
-              <a:rPr lang="en-US" sz="5000" b="1" i="1" dirty="0">
-                <a:solidFill>
-                  <a:srgbClr val="FFFFFF"/>
-                </a:solidFill>
-                <a:latin typeface="Arial" pitchFamily="34" charset="0"/>
-                <a:ea typeface="Arial" pitchFamily="34" charset="-122"/>
-                <a:cs typeface="Arial" pitchFamily="34" charset="-120"/>
-              </a:rPr>
-              <a:t>радість спасіння (радість спасіння)</a:t>
-            </a:r>
-            <a:endParaRPr lang="en-US" sz="5000" dirty="0"/>
-          </a:p>
-          <a:p>
-            <a:pPr algn="ctr" indent="0" marL="0">
-              <a:buNone/>
-            </a:pPr>
-            <a:r>
-              <a:rPr lang="en-US" sz="5000" b="1" i="1" dirty="0">
-                <a:solidFill>
-                  <a:srgbClr val="FFFFFF"/>
-                </a:solidFill>
-                <a:latin typeface="Arial" pitchFamily="34" charset="0"/>
-                <a:ea typeface="Arial" pitchFamily="34" charset="-122"/>
-                <a:cs typeface="Arial" pitchFamily="34" charset="-120"/>
-              </a:rPr>
-              <a:t>і вічне життя дарував (дарував).</a:t>
-            </a:r>
-            <a:endParaRPr lang="en-US" sz="5000" dirty="0"/>
+              <a:t>радість спасіння і вічне життя дарував.</a:t>
+            </a:r>
+            <a:endParaRPr lang="en-US" sz="4500" dirty="0"/>
           </a:p>
         </p:txBody>
       </p:sp>
@@ -2892,7 +2773,7 @@
               <a:buNone/>
             </a:pPr>
             <a:r>
-              <a:rPr lang="en-US" sz="5000" b="1" i="1" dirty="0">
+              <a:rPr lang="en-US" sz="4500" b="1" i="1" dirty="0">
                 <a:solidFill>
                   <a:srgbClr val="FFFFFF"/>
                 </a:solidFill>
@@ -2900,16 +2781,16 @@
                 <a:ea typeface="Arial" pitchFamily="34" charset="-122"/>
                 <a:cs typeface="Arial" pitchFamily="34" charset="-120"/>
               </a:rPr>
-              <a:t>Серце нове (серце нове)</a:t>
-            </a:r>
-            <a:endParaRPr lang="en-US" sz="5000" dirty="0"/>
+              <a:t>Серце нове Бог дав мені,</a:t>
+            </a:r>
+            <a:endParaRPr lang="en-US" sz="4500" dirty="0"/>
           </a:p>
           <a:p>
             <a:pPr algn="ctr" indent="0" marL="0">
               <a:buNone/>
             </a:pPr>
             <a:r>
-              <a:rPr lang="en-US" sz="5000" b="1" i="1" dirty="0">
+              <a:rPr lang="en-US" sz="4500" b="1" i="1" dirty="0">
                 <a:solidFill>
                   <a:srgbClr val="FFFFFF"/>
                 </a:solidFill>
@@ -2917,43 +2798,9 @@
                 <a:ea typeface="Arial" pitchFamily="34" charset="-122"/>
                 <a:cs typeface="Arial" pitchFamily="34" charset="-120"/>
               </a:rPr>
-              <a:t>Бог дав мені (дав мені),</a:t>
-            </a:r>
-            <a:endParaRPr lang="en-US" sz="5000" dirty="0"/>
-          </a:p>
-          <a:p>
-            <a:pPr algn="ctr" indent="0" marL="0">
-              <a:buNone/>
-            </a:pPr>
-            <a:r>
-              <a:rPr lang="en-US" sz="5000" b="1" i="1" dirty="0">
-                <a:solidFill>
-                  <a:srgbClr val="FFFFFF"/>
-                </a:solidFill>
-                <a:latin typeface="Arial" pitchFamily="34" charset="0"/>
-                <a:ea typeface="Arial" pitchFamily="34" charset="-122"/>
-                <a:cs typeface="Arial" pitchFamily="34" charset="-120"/>
-              </a:rPr>
-              <a:t>радість спасіння (радість спасіння)</a:t>
-            </a:r>
-            <a:endParaRPr lang="en-US" sz="5000" dirty="0"/>
-          </a:p>
-          <a:p>
-            <a:pPr algn="ctr" indent="0" marL="0">
-              <a:buNone/>
-            </a:pPr>
-            <a:r>
-              <a:rPr lang="en-US" sz="5000" b="1" i="1" dirty="0">
-                <a:solidFill>
-                  <a:srgbClr val="FFFFFF"/>
-                </a:solidFill>
-                <a:latin typeface="Arial" pitchFamily="34" charset="0"/>
-                <a:ea typeface="Arial" pitchFamily="34" charset="-122"/>
-                <a:cs typeface="Arial" pitchFamily="34" charset="-120"/>
-              </a:rPr>
-              <a:t>і вічне життя дарував (дарував).</a:t>
-            </a:r>
-            <a:endParaRPr lang="en-US" sz="5000" dirty="0"/>
+              <a:t>радість спасіння і вічне життя дарував.</a:t>
+            </a:r>
+            <a:endParaRPr lang="en-US" sz="4500" dirty="0"/>
           </a:p>
         </p:txBody>
       </p:sp>
@@ -3136,7 +2983,7 @@
               <a:buNone/>
             </a:pPr>
             <a:r>
-              <a:rPr lang="en-US" sz="5000" b="1" i="1" dirty="0">
+              <a:rPr lang="en-US" sz="4500" b="1" i="1" dirty="0">
                 <a:solidFill>
                   <a:srgbClr val="FFFFFF"/>
                 </a:solidFill>
@@ -3144,16 +2991,16 @@
                 <a:ea typeface="Arial" pitchFamily="34" charset="-122"/>
                 <a:cs typeface="Arial" pitchFamily="34" charset="-120"/>
               </a:rPr>
-              <a:t>Серце нове (серце нове)</a:t>
-            </a:r>
-            <a:endParaRPr lang="en-US" sz="5000" dirty="0"/>
+              <a:t>Серце нове Бог дав мені,</a:t>
+            </a:r>
+            <a:endParaRPr lang="en-US" sz="4500" dirty="0"/>
           </a:p>
           <a:p>
             <a:pPr algn="ctr" indent="0" marL="0">
               <a:buNone/>
             </a:pPr>
             <a:r>
-              <a:rPr lang="en-US" sz="5000" b="1" i="1" dirty="0">
+              <a:rPr lang="en-US" sz="4500" b="1" i="1" dirty="0">
                 <a:solidFill>
                   <a:srgbClr val="FFFFFF"/>
                 </a:solidFill>
@@ -3161,43 +3008,9 @@
                 <a:ea typeface="Arial" pitchFamily="34" charset="-122"/>
                 <a:cs typeface="Arial" pitchFamily="34" charset="-120"/>
               </a:rPr>
-              <a:t>Бог дав мені (дав мені),</a:t>
-            </a:r>
-            <a:endParaRPr lang="en-US" sz="5000" dirty="0"/>
-          </a:p>
-          <a:p>
-            <a:pPr algn="ctr" indent="0" marL="0">
-              <a:buNone/>
-            </a:pPr>
-            <a:r>
-              <a:rPr lang="en-US" sz="5000" b="1" i="1" dirty="0">
-                <a:solidFill>
-                  <a:srgbClr val="FFFFFF"/>
-                </a:solidFill>
-                <a:latin typeface="Arial" pitchFamily="34" charset="0"/>
-                <a:ea typeface="Arial" pitchFamily="34" charset="-122"/>
-                <a:cs typeface="Arial" pitchFamily="34" charset="-120"/>
-              </a:rPr>
-              <a:t>радість спасіння (радість спасіння)</a:t>
-            </a:r>
-            <a:endParaRPr lang="en-US" sz="5000" dirty="0"/>
-          </a:p>
-          <a:p>
-            <a:pPr algn="ctr" indent="0" marL="0">
-              <a:buNone/>
-            </a:pPr>
-            <a:r>
-              <a:rPr lang="en-US" sz="5000" b="1" i="1" dirty="0">
-                <a:solidFill>
-                  <a:srgbClr val="FFFFFF"/>
-                </a:solidFill>
-                <a:latin typeface="Arial" pitchFamily="34" charset="0"/>
-                <a:ea typeface="Arial" pitchFamily="34" charset="-122"/>
-                <a:cs typeface="Arial" pitchFamily="34" charset="-120"/>
-              </a:rPr>
-              <a:t>і вічне життя дарував (дарував).</a:t>
-            </a:r>
-            <a:endParaRPr lang="en-US" sz="5000" dirty="0"/>
+              <a:t>радість спасіння і вічне життя дарував.</a:t>
+            </a:r>
+            <a:endParaRPr lang="en-US" sz="4500" dirty="0"/>
           </a:p>
         </p:txBody>
       </p:sp>

</xml_diff>